<commit_message>
Modified the polynomial for the new data schemas
</commit_message>
<xml_diff>
--- a/units/unit07_loopopt/loopopt.pptx
+++ b/units/unit07_loopopt/loopopt.pptx
@@ -252,7 +252,7 @@
           <a:p>
             <a:fld id="{B7D6DDD3-D7E9-488B-B626-1E8285E424D8}" type="datetimeFigureOut">
               <a:rPr lang="en-US" smtClean="0"/>
-              <a:t>3/30/2026</a:t>
+              <a:t>4/1/2026</a:t>
             </a:fld>
             <a:endParaRPr lang="en-US"/>
           </a:p>
@@ -4052,8 +4052,8 @@
           <a:lstStyle/>
           <a:p>
             <a:r>
-              <a:rPr lang="en-US" sz="6600" dirty="0"/>
-              <a:t>Unit 6 </a:t>
+              <a:rPr lang="en-US" sz="6600"/>
+              <a:t>Unit 7 </a:t>
             </a:r>
             <a:br>
               <a:rPr lang="en-US" sz="6600" dirty="0"/>
@@ -16784,8 +16784,8 @@
           </a:p>
         </p:txBody>
       </p:sp>
-      <mc:AlternateContent xmlns:mc="http://schemas.openxmlformats.org/markup-compatibility/2006">
-        <mc:Choice xmlns:a14="http://schemas.microsoft.com/office/drawing/2010/main" Requires="a14">
+      <mc:AlternateContent xmlns:mc="http://schemas.openxmlformats.org/markup-compatibility/2006" xmlns:a14="http://schemas.microsoft.com/office/drawing/2010/main">
+        <mc:Choice Requires="a14">
           <p:sp>
             <p:nvSpPr>
               <p:cNvPr id="11" name="TextBox 10">
@@ -16851,7 +16851,7 @@
             </p:txBody>
           </p:sp>
         </mc:Choice>
-        <mc:Fallback>
+        <mc:Fallback xmlns="">
           <p:sp>
             <p:nvSpPr>
               <p:cNvPr id="11" name="TextBox 10">
@@ -17132,8 +17132,8 @@
           </a:fontRef>
         </p:style>
       </p:cxnSp>
-      <mc:AlternateContent xmlns:mc="http://schemas.openxmlformats.org/markup-compatibility/2006">
-        <mc:Choice xmlns:a14="http://schemas.microsoft.com/office/drawing/2010/main" Requires="a14">
+      <mc:AlternateContent xmlns:mc="http://schemas.openxmlformats.org/markup-compatibility/2006" xmlns:a14="http://schemas.microsoft.com/office/drawing/2010/main">
+        <mc:Choice Requires="a14">
           <p:sp>
             <p:nvSpPr>
               <p:cNvPr id="20" name="TextBox 19">
@@ -17199,7 +17199,7 @@
             </p:txBody>
           </p:sp>
         </mc:Choice>
-        <mc:Fallback>
+        <mc:Fallback xmlns="">
           <p:sp>
             <p:nvSpPr>
               <p:cNvPr id="20" name="TextBox 19">
@@ -19059,8 +19059,8 @@
           </a:p>
         </p:txBody>
       </p:sp>
-      <mc:AlternateContent xmlns:mc="http://schemas.openxmlformats.org/markup-compatibility/2006">
-        <mc:Choice xmlns:a14="http://schemas.microsoft.com/office/drawing/2010/main" Requires="a14">
+      <mc:AlternateContent xmlns:mc="http://schemas.openxmlformats.org/markup-compatibility/2006" xmlns:a14="http://schemas.microsoft.com/office/drawing/2010/main">
+        <mc:Choice Requires="a14">
           <p:sp>
             <p:nvSpPr>
               <p:cNvPr id="3" name="Content Placeholder 2">
@@ -19378,7 +19378,7 @@
             </p:txBody>
           </p:sp>
         </mc:Choice>
-        <mc:Fallback>
+        <mc:Fallback xmlns="">
           <p:sp>
             <p:nvSpPr>
               <p:cNvPr id="3" name="Content Placeholder 2">
@@ -19564,8 +19564,8 @@
           </a:p>
         </p:txBody>
       </p:sp>
-      <mc:AlternateContent xmlns:mc="http://schemas.openxmlformats.org/markup-compatibility/2006">
-        <mc:Choice xmlns:a14="http://schemas.microsoft.com/office/drawing/2010/main" Requires="a14">
+      <mc:AlternateContent xmlns:mc="http://schemas.openxmlformats.org/markup-compatibility/2006" xmlns:a14="http://schemas.microsoft.com/office/drawing/2010/main">
+        <mc:Choice Requires="a14">
           <p:graphicFrame>
             <p:nvGraphicFramePr>
               <p:cNvPr id="5" name="Table 4">
@@ -19618,6 +19618,7 @@
                         <a:bodyPr/>
                         <a:lstStyle/>
                         <a:p>
+                          <a:pPr/>
                           <a14:m>
                             <m:oMathPara xmlns:m="http://schemas.openxmlformats.org/officeDocument/2006/math">
                               <m:oMathParaPr>
@@ -19680,6 +19681,7 @@
                         <a:bodyPr/>
                         <a:lstStyle/>
                         <a:p>
+                          <a:pPr/>
                           <a14:m>
                             <m:oMathPara xmlns:m="http://schemas.openxmlformats.org/officeDocument/2006/math">
                               <m:oMathParaPr>
@@ -19847,7 +19849,7 @@
             </a:graphic>
           </p:graphicFrame>
         </mc:Choice>
-        <mc:Fallback>
+        <mc:Fallback xmlns="">
           <p:graphicFrame>
             <p:nvGraphicFramePr>
               <p:cNvPr id="5" name="Table 4">
@@ -20040,8 +20042,8 @@
           </p:graphicFrame>
         </mc:Fallback>
       </mc:AlternateContent>
-      <mc:AlternateContent xmlns:mc="http://schemas.openxmlformats.org/markup-compatibility/2006">
-        <mc:Choice xmlns:a14="http://schemas.microsoft.com/office/drawing/2010/main" Requires="a14">
+      <mc:AlternateContent xmlns:mc="http://schemas.openxmlformats.org/markup-compatibility/2006" xmlns:a14="http://schemas.microsoft.com/office/drawing/2010/main">
+        <mc:Choice Requires="a14">
           <p:graphicFrame>
             <p:nvGraphicFramePr>
               <p:cNvPr id="6" name="Table 5">
@@ -20122,6 +20124,7 @@
                         <a:bodyPr/>
                         <a:lstStyle/>
                         <a:p>
+                          <a:pPr/>
                           <a14:m>
                             <m:oMathPara xmlns:m="http://schemas.openxmlformats.org/officeDocument/2006/math">
                               <m:oMathParaPr>
@@ -20147,6 +20150,7 @@
                         <a:bodyPr/>
                         <a:lstStyle/>
                         <a:p>
+                          <a:pPr/>
                           <a14:m>
                             <m:oMathPara xmlns:m="http://schemas.openxmlformats.org/officeDocument/2006/math">
                               <m:oMathParaPr>
@@ -20172,6 +20176,7 @@
                         <a:bodyPr/>
                         <a:lstStyle/>
                         <a:p>
+                          <a:pPr/>
                           <a14:m>
                             <m:oMathPara xmlns:m="http://schemas.openxmlformats.org/officeDocument/2006/math">
                               <m:oMathParaPr>
@@ -20197,6 +20202,7 @@
                         <a:bodyPr/>
                         <a:lstStyle/>
                         <a:p>
+                          <a:pPr/>
                           <a14:m>
                             <m:oMathPara xmlns:m="http://schemas.openxmlformats.org/officeDocument/2006/math">
                               <m:oMathParaPr>
@@ -20259,6 +20265,7 @@
                         <a:bodyPr/>
                         <a:lstStyle/>
                         <a:p>
+                          <a:pPr/>
                           <a14:m>
                             <m:oMathPara xmlns:m="http://schemas.openxmlformats.org/officeDocument/2006/math">
                               <m:oMathParaPr>
@@ -20321,6 +20328,7 @@
                         <a:bodyPr/>
                         <a:lstStyle/>
                         <a:p>
+                          <a:pPr/>
                           <a14:m>
                             <m:oMathPara xmlns:m="http://schemas.openxmlformats.org/officeDocument/2006/math">
                               <m:oMathParaPr>
@@ -20880,7 +20888,7 @@
             </a:graphic>
           </p:graphicFrame>
         </mc:Choice>
-        <mc:Fallback>
+        <mc:Fallback xmlns="">
           <p:graphicFrame>
             <p:nvGraphicFramePr>
               <p:cNvPr id="6" name="Table 5">
@@ -21638,8 +21646,8 @@
           </a:p>
         </p:txBody>
       </p:sp>
-      <mc:AlternateContent xmlns:mc="http://schemas.openxmlformats.org/markup-compatibility/2006">
-        <mc:Choice xmlns:a14="http://schemas.microsoft.com/office/drawing/2010/main" Requires="a14">
+      <mc:AlternateContent xmlns:mc="http://schemas.openxmlformats.org/markup-compatibility/2006" xmlns:a14="http://schemas.microsoft.com/office/drawing/2010/main">
+        <mc:Choice Requires="a14">
           <p:sp>
             <p:nvSpPr>
               <p:cNvPr id="3" name="Content Placeholder 2">
@@ -21843,7 +21851,7 @@
             </p:txBody>
           </p:sp>
         </mc:Choice>
-        <mc:Fallback>
+        <mc:Fallback xmlns="">
           <p:sp>
             <p:nvSpPr>
               <p:cNvPr id="3" name="Content Placeholder 2">
@@ -22928,8 +22936,8 @@
           </a:p>
         </p:txBody>
       </p:sp>
-      <mc:AlternateContent xmlns:mc="http://schemas.openxmlformats.org/markup-compatibility/2006">
-        <mc:Choice xmlns:a14="http://schemas.microsoft.com/office/drawing/2010/main" Requires="a14">
+      <mc:AlternateContent xmlns:mc="http://schemas.openxmlformats.org/markup-compatibility/2006" xmlns:a14="http://schemas.microsoft.com/office/drawing/2010/main">
+        <mc:Choice Requires="a14">
           <p:sp>
             <p:nvSpPr>
               <p:cNvPr id="3" name="Content Placeholder 2">
@@ -22997,7 +23005,7 @@
             </p:txBody>
           </p:sp>
         </mc:Choice>
-        <mc:Fallback>
+        <mc:Fallback xmlns="">
           <p:sp>
             <p:nvSpPr>
               <p:cNvPr id="3" name="Content Placeholder 2">
@@ -23224,8 +23232,8 @@
           </a:p>
         </p:txBody>
       </p:sp>
-      <mc:AlternateContent xmlns:mc="http://schemas.openxmlformats.org/markup-compatibility/2006">
-        <mc:Choice xmlns:a14="http://schemas.microsoft.com/office/drawing/2010/main" Requires="a14">
+      <mc:AlternateContent xmlns:mc="http://schemas.openxmlformats.org/markup-compatibility/2006" xmlns:a14="http://schemas.microsoft.com/office/drawing/2010/main">
+        <mc:Choice Requires="a14">
           <p:sp>
             <p:nvSpPr>
               <p:cNvPr id="3" name="Content Placeholder 2">
@@ -23347,7 +23355,7 @@
             </p:txBody>
           </p:sp>
         </mc:Choice>
-        <mc:Fallback>
+        <mc:Fallback xmlns="">
           <p:sp>
             <p:nvSpPr>
               <p:cNvPr id="3" name="Content Placeholder 2">
@@ -23812,8 +23820,8 @@
           </a:p>
         </p:txBody>
       </p:sp>
-      <mc:AlternateContent xmlns:mc="http://schemas.openxmlformats.org/markup-compatibility/2006">
-        <mc:Choice xmlns:a14="http://schemas.microsoft.com/office/drawing/2010/main" Requires="a14">
+      <mc:AlternateContent xmlns:mc="http://schemas.openxmlformats.org/markup-compatibility/2006" xmlns:a14="http://schemas.microsoft.com/office/drawing/2010/main">
+        <mc:Choice Requires="a14">
           <p:sp>
             <p:nvSpPr>
               <p:cNvPr id="12" name="TextBox 11">
@@ -23932,7 +23940,7 @@
             </p:txBody>
           </p:sp>
         </mc:Choice>
-        <mc:Fallback>
+        <mc:Fallback xmlns="">
           <p:sp>
             <p:nvSpPr>
               <p:cNvPr id="12" name="TextBox 11">
@@ -24066,8 +24074,8 @@
           </a:fontRef>
         </p:style>
       </p:cxnSp>
-      <mc:AlternateContent xmlns:mc="http://schemas.openxmlformats.org/markup-compatibility/2006">
-        <mc:Choice xmlns:a14="http://schemas.microsoft.com/office/drawing/2010/main" Requires="a14">
+      <mc:AlternateContent xmlns:mc="http://schemas.openxmlformats.org/markup-compatibility/2006" xmlns:a14="http://schemas.microsoft.com/office/drawing/2010/main">
+        <mc:Choice Requires="a14">
           <p:sp>
             <p:nvSpPr>
               <p:cNvPr id="15" name="TextBox 14">
@@ -24162,7 +24170,7 @@
             </p:txBody>
           </p:sp>
         </mc:Choice>
-        <mc:Fallback>
+        <mc:Fallback xmlns="">
           <p:sp>
             <p:nvSpPr>
               <p:cNvPr id="15" name="TextBox 14">
@@ -24207,8 +24215,8 @@
           </p:sp>
         </mc:Fallback>
       </mc:AlternateContent>
-      <mc:AlternateContent xmlns:mc="http://schemas.openxmlformats.org/markup-compatibility/2006">
-        <mc:Choice xmlns:a14="http://schemas.microsoft.com/office/drawing/2010/main" Requires="a14">
+      <mc:AlternateContent xmlns:mc="http://schemas.openxmlformats.org/markup-compatibility/2006" xmlns:a14="http://schemas.microsoft.com/office/drawing/2010/main">
+        <mc:Choice Requires="a14">
           <p:sp>
             <p:nvSpPr>
               <p:cNvPr id="16" name="TextBox 15">
@@ -24265,7 +24273,7 @@
             </p:txBody>
           </p:sp>
         </mc:Choice>
-        <mc:Fallback>
+        <mc:Fallback xmlns="">
           <p:sp>
             <p:nvSpPr>
               <p:cNvPr id="16" name="TextBox 15">
@@ -24310,8 +24318,8 @@
           </p:sp>
         </mc:Fallback>
       </mc:AlternateContent>
-      <mc:AlternateContent xmlns:mc="http://schemas.openxmlformats.org/markup-compatibility/2006">
-        <mc:Choice xmlns:a14="http://schemas.microsoft.com/office/drawing/2010/main" Requires="a14">
+      <mc:AlternateContent xmlns:mc="http://schemas.openxmlformats.org/markup-compatibility/2006" xmlns:a14="http://schemas.microsoft.com/office/drawing/2010/main">
+        <mc:Choice Requires="a14">
           <p:sp>
             <p:nvSpPr>
               <p:cNvPr id="17" name="TextBox 16">
@@ -24374,7 +24382,7 @@
             </p:txBody>
           </p:sp>
         </mc:Choice>
-        <mc:Fallback>
+        <mc:Fallback xmlns="">
           <p:sp>
             <p:nvSpPr>
               <p:cNvPr id="17" name="TextBox 16">
@@ -24419,8 +24427,8 @@
           </p:sp>
         </mc:Fallback>
       </mc:AlternateContent>
-      <mc:AlternateContent xmlns:mc="http://schemas.openxmlformats.org/markup-compatibility/2006">
-        <mc:Choice xmlns:a14="http://schemas.microsoft.com/office/drawing/2010/main" Requires="a14">
+      <mc:AlternateContent xmlns:mc="http://schemas.openxmlformats.org/markup-compatibility/2006" xmlns:a14="http://schemas.microsoft.com/office/drawing/2010/main">
+        <mc:Choice Requires="a14">
           <p:sp>
             <p:nvSpPr>
               <p:cNvPr id="18" name="TextBox 17">
@@ -24483,7 +24491,7 @@
             </p:txBody>
           </p:sp>
         </mc:Choice>
-        <mc:Fallback>
+        <mc:Fallback xmlns="">
           <p:sp>
             <p:nvSpPr>
               <p:cNvPr id="18" name="TextBox 17">
@@ -25429,8 +25437,8 @@
           </p:style>
         </p:cxnSp>
       </p:grpSp>
-      <mc:AlternateContent xmlns:mc="http://schemas.openxmlformats.org/markup-compatibility/2006">
-        <mc:Choice xmlns:a14="http://schemas.microsoft.com/office/drawing/2010/main" Requires="a14">
+      <mc:AlternateContent xmlns:mc="http://schemas.openxmlformats.org/markup-compatibility/2006" xmlns:a14="http://schemas.microsoft.com/office/drawing/2010/main">
+        <mc:Choice Requires="a14">
           <p:sp>
             <p:nvSpPr>
               <p:cNvPr id="29" name="TextBox 28">
@@ -25507,7 +25515,7 @@
             </p:txBody>
           </p:sp>
         </mc:Choice>
-        <mc:Fallback>
+        <mc:Fallback xmlns="">
           <p:sp>
             <p:nvSpPr>
               <p:cNvPr id="29" name="TextBox 28">
@@ -26032,8 +26040,8 @@
           </a:p>
         </p:txBody>
       </p:sp>
-      <mc:AlternateContent xmlns:mc="http://schemas.openxmlformats.org/markup-compatibility/2006">
-        <mc:Choice xmlns:a14="http://schemas.microsoft.com/office/drawing/2010/main" Requires="a14">
+      <mc:AlternateContent xmlns:mc="http://schemas.openxmlformats.org/markup-compatibility/2006" xmlns:a14="http://schemas.microsoft.com/office/drawing/2010/main">
+        <mc:Choice Requires="a14">
           <p:sp>
             <p:nvSpPr>
               <p:cNvPr id="7" name="TextBox 6">
@@ -26096,7 +26104,7 @@
             </p:txBody>
           </p:sp>
         </mc:Choice>
-        <mc:Fallback>
+        <mc:Fallback xmlns="">
           <p:sp>
             <p:nvSpPr>
               <p:cNvPr id="7" name="TextBox 6">

</xml_diff>